<commit_message>
Revisa minicurso para contrato v1.3 e apresentação reproduzível em R
</commit_message>
<xml_diff>
--- a/03-relatorio-qmd/template-referencia.pptx
+++ b/03-relatorio-qmd/template-referencia.pptx
@@ -688,6 +688,14 @@
 <file path=ppt/slideLayouts/slideLayout1.xml><?xml version="1.0" encoding="utf-8"?>
 <p:sldLayout xmlns:a="http://schemas.openxmlformats.org/drawingml/2006/main" xmlns:r="http://schemas.openxmlformats.org/officeDocument/2006/relationships" xmlns:p="http://schemas.openxmlformats.org/presentationml/2006/main" type="title" preserve="1">
   <p:cSld name="Title Slide">
+    <p:bg>
+      <p:bgPr>
+        <a:solidFill>
+          <a:srgbClr val="0C2440"/>
+        </a:solidFill>
+        <a:effectLst/>
+      </p:bgPr>
+    </p:bg>
     <p:spTree>
       <p:nvGrpSpPr>
         <p:cNvPr id="1" name=""/>
@@ -704,6 +712,49 @@
       </p:grpSpPr>
       <p:sp>
         <p:nvSpPr>
+          <p:cNvPr id="105" name="Rectangle 1"/>
+          <p:cNvSpPr/>
+          <p:nvPr/>
+        </p:nvSpPr>
+        <p:spPr>
+          <a:xfrm>
+            <a:off x="0" y="0"/>
+            <a:ext cx="164592" cy="5143500"/>
+          </a:xfrm>
+          <a:prstGeom prst="rect">
+            <a:avLst/>
+          </a:prstGeom>
+          <a:solidFill>
+            <a:srgbClr val="49A9DF"/>
+          </a:solidFill>
+          <a:ln>
+            <a:noFill/>
+          </a:ln>
+        </p:spPr>
+        <p:style>
+          <a:lnRef idx="1">
+            <a:schemeClr val="accent1"/>
+          </a:lnRef>
+          <a:fillRef idx="3">
+            <a:schemeClr val="accent1"/>
+          </a:fillRef>
+          <a:effectRef idx="2">
+            <a:schemeClr val="accent1"/>
+          </a:effectRef>
+          <a:fontRef idx="minor">
+            <a:schemeClr val="lt1"/>
+          </a:fontRef>
+        </p:style>
+        <p:txBody>
+          <a:bodyPr rtlCol="0" anchor="ctr"/>
+          <a:lstStyle/>
+          <a:p>
+            <a:pPr algn="ctr"/>
+          </a:p>
+        </p:txBody>
+      </p:sp>
+      <p:sp>
+        <p:nvSpPr>
           <p:cNvPr id="2" name="Title 1"/>
           <p:cNvSpPr>
             <a:spLocks noGrp="1"/>
@@ -722,6 +773,14 @@
           <a:bodyPr/>
           <a:lstStyle/>
           <a:p>
+            <a:pPr>
+              <a:defRPr sz="4700" b="1">
+                <a:solidFill>
+                  <a:srgbClr val="FFFFFF"/>
+                </a:solidFill>
+                <a:latin typeface="Aptos Display"/>
+              </a:defRPr>
+            </a:pPr>
             <a:r>
               <a:rPr lang="en-US"/>
               <a:t>Click to edit Master title style</a:t>
@@ -840,6 +899,14 @@
             </a:lvl9pPr>
           </a:lstStyle>
           <a:p>
+            <a:pPr>
+              <a:defRPr sz="4700" b="1">
+                <a:solidFill>
+                  <a:srgbClr val="FFFFFF"/>
+                </a:solidFill>
+                <a:latin typeface="Aptos Display"/>
+              </a:defRPr>
+            </a:pPr>
             <a:r>
               <a:rPr lang="en-US"/>
               <a:t>Click to edit Master subtitle style</a:t>
@@ -862,6 +929,14 @@
           <a:bodyPr/>
           <a:lstStyle/>
           <a:p>
+            <a:pPr>
+              <a:defRPr sz="900" b="0">
+                <a:solidFill>
+                  <a:srgbClr val="CBE8F9"/>
+                </a:solidFill>
+                <a:latin typeface="Aptos"/>
+              </a:defRPr>
+            </a:pPr>
             <a:fld id="{241EB5C9-1307-BA42-ABA2-0BC069CD8E7F}" type="datetimeFigureOut">
               <a:rPr lang="en-US" smtClean="0"/>
               <a:t>1/2/22</a:t>
@@ -885,6 +960,14 @@
           <a:bodyPr/>
           <a:lstStyle/>
           <a:p>
+            <a:pPr>
+              <a:defRPr sz="900" b="0">
+                <a:solidFill>
+                  <a:srgbClr val="CBE8F9"/>
+                </a:solidFill>
+                <a:latin typeface="Aptos"/>
+              </a:defRPr>
+            </a:pPr>
             <a:endParaRPr lang="en-US"/>
           </a:p>
         </p:txBody>
@@ -904,6 +987,14 @@
           <a:bodyPr/>
           <a:lstStyle/>
           <a:p>
+            <a:pPr>
+              <a:defRPr sz="900" b="0">
+                <a:solidFill>
+                  <a:srgbClr val="CBE8F9"/>
+                </a:solidFill>
+                <a:latin typeface="Aptos"/>
+              </a:defRPr>
+            </a:pPr>
             <a:fld id="{C5EF2332-01BF-834F-8236-50238282D533}" type="slidenum">
               <a:rPr lang="en-US" smtClean="0"/>
               <a:t>‹#›</a:t>
@@ -928,6 +1019,14 @@
 <file path=ppt/slideLayouts/slideLayout10.xml><?xml version="1.0" encoding="utf-8"?>
 <p:sldLayout xmlns:a="http://schemas.openxmlformats.org/drawingml/2006/main" xmlns:r="http://schemas.openxmlformats.org/officeDocument/2006/relationships" xmlns:p="http://schemas.openxmlformats.org/presentationml/2006/main" type="vertTx" preserve="1">
   <p:cSld name="Title and Vertical Text">
+    <p:bg>
+      <p:bgPr>
+        <a:solidFill>
+          <a:srgbClr val="FFFFFF"/>
+        </a:solidFill>
+        <a:effectLst/>
+      </p:bgPr>
+    </p:bg>
     <p:spTree>
       <p:nvGrpSpPr>
         <p:cNvPr id="1" name=""/>
@@ -944,6 +1043,49 @@
       </p:grpSpPr>
       <p:sp>
         <p:nvSpPr>
+          <p:cNvPr id="105" name="Rectangle 1"/>
+          <p:cNvSpPr/>
+          <p:nvPr/>
+        </p:nvSpPr>
+        <p:spPr>
+          <a:xfrm>
+            <a:off x="457200" y="1024128"/>
+            <a:ext cx="8229600" cy="50292"/>
+          </a:xfrm>
+          <a:prstGeom prst="rect">
+            <a:avLst/>
+          </a:prstGeom>
+          <a:solidFill>
+            <a:srgbClr val="49A9DF"/>
+          </a:solidFill>
+          <a:ln>
+            <a:noFill/>
+          </a:ln>
+        </p:spPr>
+        <p:style>
+          <a:lnRef idx="1">
+            <a:schemeClr val="accent1"/>
+          </a:lnRef>
+          <a:fillRef idx="3">
+            <a:schemeClr val="accent1"/>
+          </a:fillRef>
+          <a:effectRef idx="2">
+            <a:schemeClr val="accent1"/>
+          </a:effectRef>
+          <a:fontRef idx="minor">
+            <a:schemeClr val="lt1"/>
+          </a:fontRef>
+        </p:style>
+        <p:txBody>
+          <a:bodyPr rtlCol="0" anchor="ctr"/>
+          <a:lstStyle/>
+          <a:p>
+            <a:pPr algn="ctr"/>
+          </a:p>
+        </p:txBody>
+      </p:sp>
+      <p:sp>
+        <p:nvSpPr>
           <p:cNvPr id="2" name="Title 1"/>
           <p:cNvSpPr>
             <a:spLocks noGrp="1"/>
@@ -957,6 +1099,14 @@
           <a:bodyPr/>
           <a:lstStyle/>
           <a:p>
+            <a:pPr>
+              <a:defRPr sz="3100" b="1">
+                <a:solidFill>
+                  <a:srgbClr val="0C2440"/>
+                </a:solidFill>
+                <a:latin typeface="Aptos Display"/>
+              </a:defRPr>
+            </a:pPr>
             <a:r>
               <a:rPr lang="en-US"/>
               <a:t>Click to edit Master title style</a:t>
@@ -979,7 +1129,14 @@
           <a:bodyPr vert="eaVert"/>
           <a:lstStyle/>
           <a:p>
-            <a:pPr lvl="0"/>
+            <a:pPr lvl="0">
+              <a:defRPr sz="1900" b="0">
+                <a:solidFill>
+                  <a:srgbClr val="243A50"/>
+                </a:solidFill>
+                <a:latin typeface="Aptos"/>
+              </a:defRPr>
+            </a:pPr>
             <a:r>
               <a:rPr lang="en-US"/>
               <a:t>Click to edit Master text styles</a:t>
@@ -1030,6 +1187,14 @@
           <a:bodyPr/>
           <a:lstStyle/>
           <a:p>
+            <a:pPr>
+              <a:defRPr sz="900" b="0">
+                <a:solidFill>
+                  <a:srgbClr val="637D94"/>
+                </a:solidFill>
+                <a:latin typeface="Aptos"/>
+              </a:defRPr>
+            </a:pPr>
             <a:fld id="{241EB5C9-1307-BA42-ABA2-0BC069CD8E7F}" type="datetimeFigureOut">
               <a:rPr lang="en-US" smtClean="0"/>
               <a:t>1/2/22</a:t>
@@ -1053,6 +1218,14 @@
           <a:bodyPr/>
           <a:lstStyle/>
           <a:p>
+            <a:pPr>
+              <a:defRPr sz="900" b="0">
+                <a:solidFill>
+                  <a:srgbClr val="637D94"/>
+                </a:solidFill>
+                <a:latin typeface="Aptos"/>
+              </a:defRPr>
+            </a:pPr>
             <a:endParaRPr lang="en-US"/>
           </a:p>
         </p:txBody>
@@ -1072,6 +1245,14 @@
           <a:bodyPr/>
           <a:lstStyle/>
           <a:p>
+            <a:pPr>
+              <a:defRPr sz="900" b="0">
+                <a:solidFill>
+                  <a:srgbClr val="637D94"/>
+                </a:solidFill>
+                <a:latin typeface="Aptos"/>
+              </a:defRPr>
+            </a:pPr>
             <a:fld id="{C5EF2332-01BF-834F-8236-50238282D533}" type="slidenum">
               <a:rPr lang="en-US" smtClean="0"/>
               <a:t>‹#›</a:t>
@@ -1096,6 +1277,14 @@
 <file path=ppt/slideLayouts/slideLayout11.xml><?xml version="1.0" encoding="utf-8"?>
 <p:sldLayout xmlns:a="http://schemas.openxmlformats.org/drawingml/2006/main" xmlns:r="http://schemas.openxmlformats.org/officeDocument/2006/relationships" xmlns:p="http://schemas.openxmlformats.org/presentationml/2006/main" type="vertTitleAndTx" preserve="1">
   <p:cSld name="Vertical Title and Text">
+    <p:bg>
+      <p:bgPr>
+        <a:solidFill>
+          <a:srgbClr val="FFFFFF"/>
+        </a:solidFill>
+        <a:effectLst/>
+      </p:bgPr>
+    </p:bg>
     <p:spTree>
       <p:nvGrpSpPr>
         <p:cNvPr id="1" name=""/>
@@ -1112,6 +1301,49 @@
       </p:grpSpPr>
       <p:sp>
         <p:nvSpPr>
+          <p:cNvPr id="105" name="Rectangle 1"/>
+          <p:cNvSpPr/>
+          <p:nvPr/>
+        </p:nvSpPr>
+        <p:spPr>
+          <a:xfrm>
+            <a:off x="457200" y="1024128"/>
+            <a:ext cx="8229600" cy="50292"/>
+          </a:xfrm>
+          <a:prstGeom prst="rect">
+            <a:avLst/>
+          </a:prstGeom>
+          <a:solidFill>
+            <a:srgbClr val="49A9DF"/>
+          </a:solidFill>
+          <a:ln>
+            <a:noFill/>
+          </a:ln>
+        </p:spPr>
+        <p:style>
+          <a:lnRef idx="1">
+            <a:schemeClr val="accent1"/>
+          </a:lnRef>
+          <a:fillRef idx="3">
+            <a:schemeClr val="accent1"/>
+          </a:fillRef>
+          <a:effectRef idx="2">
+            <a:schemeClr val="accent1"/>
+          </a:effectRef>
+          <a:fontRef idx="minor">
+            <a:schemeClr val="lt1"/>
+          </a:fontRef>
+        </p:style>
+        <p:txBody>
+          <a:bodyPr rtlCol="0" anchor="ctr"/>
+          <a:lstStyle/>
+          <a:p>
+            <a:pPr algn="ctr"/>
+          </a:p>
+        </p:txBody>
+      </p:sp>
+      <p:sp>
+        <p:nvSpPr>
           <p:cNvPr id="2" name="Vertical Title 1"/>
           <p:cNvSpPr>
             <a:spLocks noGrp="1"/>
@@ -1130,6 +1362,14 @@
           <a:bodyPr vert="eaVert"/>
           <a:lstStyle/>
           <a:p>
+            <a:pPr>
+              <a:defRPr sz="3100" b="1">
+                <a:solidFill>
+                  <a:srgbClr val="0C2440"/>
+                </a:solidFill>
+                <a:latin typeface="Aptos Display"/>
+              </a:defRPr>
+            </a:pPr>
             <a:r>
               <a:rPr lang="en-US"/>
               <a:t>Click to edit Master title style</a:t>
@@ -1157,7 +1397,14 @@
           <a:bodyPr vert="eaVert"/>
           <a:lstStyle/>
           <a:p>
-            <a:pPr lvl="0"/>
+            <a:pPr lvl="0">
+              <a:defRPr sz="1900" b="0">
+                <a:solidFill>
+                  <a:srgbClr val="243A50"/>
+                </a:solidFill>
+                <a:latin typeface="Aptos"/>
+              </a:defRPr>
+            </a:pPr>
             <a:r>
               <a:rPr lang="en-US"/>
               <a:t>Click to edit Master text styles</a:t>
@@ -1208,6 +1455,14 @@
           <a:bodyPr/>
           <a:lstStyle/>
           <a:p>
+            <a:pPr>
+              <a:defRPr sz="900" b="0">
+                <a:solidFill>
+                  <a:srgbClr val="637D94"/>
+                </a:solidFill>
+                <a:latin typeface="Aptos"/>
+              </a:defRPr>
+            </a:pPr>
             <a:fld id="{241EB5C9-1307-BA42-ABA2-0BC069CD8E7F}" type="datetimeFigureOut">
               <a:rPr lang="en-US" smtClean="0"/>
               <a:t>1/2/22</a:t>
@@ -1231,6 +1486,14 @@
           <a:bodyPr/>
           <a:lstStyle/>
           <a:p>
+            <a:pPr>
+              <a:defRPr sz="900" b="0">
+                <a:solidFill>
+                  <a:srgbClr val="637D94"/>
+                </a:solidFill>
+                <a:latin typeface="Aptos"/>
+              </a:defRPr>
+            </a:pPr>
             <a:endParaRPr lang="en-US"/>
           </a:p>
         </p:txBody>
@@ -1250,6 +1513,14 @@
           <a:bodyPr/>
           <a:lstStyle/>
           <a:p>
+            <a:pPr>
+              <a:defRPr sz="900" b="0">
+                <a:solidFill>
+                  <a:srgbClr val="637D94"/>
+                </a:solidFill>
+                <a:latin typeface="Aptos"/>
+              </a:defRPr>
+            </a:pPr>
             <a:fld id="{C5EF2332-01BF-834F-8236-50238282D533}" type="slidenum">
               <a:rPr lang="en-US" smtClean="0"/>
               <a:t>‹#›</a:t>
@@ -1274,6 +1545,14 @@
 <file path=ppt/slideLayouts/slideLayout2.xml><?xml version="1.0" encoding="utf-8"?>
 <p:sldLayout xmlns:a="http://schemas.openxmlformats.org/drawingml/2006/main" xmlns:r="http://schemas.openxmlformats.org/officeDocument/2006/relationships" xmlns:p="http://schemas.openxmlformats.org/presentationml/2006/main" type="obj" preserve="1">
   <p:cSld name="Title and Content">
+    <p:bg>
+      <p:bgPr>
+        <a:solidFill>
+          <a:srgbClr val="FFFFFF"/>
+        </a:solidFill>
+        <a:effectLst/>
+      </p:bgPr>
+    </p:bg>
     <p:spTree>
       <p:nvGrpSpPr>
         <p:cNvPr id="1" name=""/>
@@ -1290,6 +1569,49 @@
       </p:grpSpPr>
       <p:sp>
         <p:nvSpPr>
+          <p:cNvPr id="105" name="Rectangle 1"/>
+          <p:cNvSpPr/>
+          <p:nvPr/>
+        </p:nvSpPr>
+        <p:spPr>
+          <a:xfrm>
+            <a:off x="457200" y="1024128"/>
+            <a:ext cx="8229600" cy="50292"/>
+          </a:xfrm>
+          <a:prstGeom prst="rect">
+            <a:avLst/>
+          </a:prstGeom>
+          <a:solidFill>
+            <a:srgbClr val="49A9DF"/>
+          </a:solidFill>
+          <a:ln>
+            <a:noFill/>
+          </a:ln>
+        </p:spPr>
+        <p:style>
+          <a:lnRef idx="1">
+            <a:schemeClr val="accent1"/>
+          </a:lnRef>
+          <a:fillRef idx="3">
+            <a:schemeClr val="accent1"/>
+          </a:fillRef>
+          <a:effectRef idx="2">
+            <a:schemeClr val="accent1"/>
+          </a:effectRef>
+          <a:fontRef idx="minor">
+            <a:schemeClr val="lt1"/>
+          </a:fontRef>
+        </p:style>
+        <p:txBody>
+          <a:bodyPr rtlCol="0" anchor="ctr"/>
+          <a:lstStyle/>
+          <a:p>
+            <a:pPr algn="ctr"/>
+          </a:p>
+        </p:txBody>
+      </p:sp>
+      <p:sp>
+        <p:nvSpPr>
           <p:cNvPr id="2" name="Title 1"/>
           <p:cNvSpPr>
             <a:spLocks noGrp="1"/>
@@ -1303,6 +1625,14 @@
           <a:bodyPr/>
           <a:lstStyle/>
           <a:p>
+            <a:pPr>
+              <a:defRPr sz="3100" b="1">
+                <a:solidFill>
+                  <a:srgbClr val="0C2440"/>
+                </a:solidFill>
+                <a:latin typeface="Aptos Display"/>
+              </a:defRPr>
+            </a:pPr>
             <a:r>
               <a:rPr lang="en-US"/>
               <a:t>Click to edit Master title style</a:t>
@@ -1325,7 +1655,14 @@
           <a:bodyPr/>
           <a:lstStyle/>
           <a:p>
-            <a:pPr lvl="0"/>
+            <a:pPr lvl="0">
+              <a:defRPr sz="1900" b="0">
+                <a:solidFill>
+                  <a:srgbClr val="243A50"/>
+                </a:solidFill>
+                <a:latin typeface="Aptos"/>
+              </a:defRPr>
+            </a:pPr>
             <a:r>
               <a:rPr lang="en-US"/>
               <a:t>Click to edit Master text styles</a:t>
@@ -1376,6 +1713,14 @@
           <a:bodyPr/>
           <a:lstStyle/>
           <a:p>
+            <a:pPr>
+              <a:defRPr sz="900" b="0">
+                <a:solidFill>
+                  <a:srgbClr val="637D94"/>
+                </a:solidFill>
+                <a:latin typeface="Aptos"/>
+              </a:defRPr>
+            </a:pPr>
             <a:fld id="{241EB5C9-1307-BA42-ABA2-0BC069CD8E7F}" type="datetimeFigureOut">
               <a:rPr lang="en-US" smtClean="0"/>
               <a:t>1/2/22</a:t>
@@ -1399,6 +1744,14 @@
           <a:bodyPr/>
           <a:lstStyle/>
           <a:p>
+            <a:pPr>
+              <a:defRPr sz="900" b="0">
+                <a:solidFill>
+                  <a:srgbClr val="637D94"/>
+                </a:solidFill>
+                <a:latin typeface="Aptos"/>
+              </a:defRPr>
+            </a:pPr>
             <a:endParaRPr lang="en-US"/>
           </a:p>
         </p:txBody>
@@ -1418,6 +1771,14 @@
           <a:bodyPr/>
           <a:lstStyle/>
           <a:p>
+            <a:pPr>
+              <a:defRPr sz="900" b="0">
+                <a:solidFill>
+                  <a:srgbClr val="637D94"/>
+                </a:solidFill>
+                <a:latin typeface="Aptos"/>
+              </a:defRPr>
+            </a:pPr>
             <a:fld id="{C5EF2332-01BF-834F-8236-50238282D533}" type="slidenum">
               <a:rPr lang="en-US" smtClean="0"/>
               <a:t>‹#›</a:t>
@@ -1442,6 +1803,14 @@
 <file path=ppt/slideLayouts/slideLayout3.xml><?xml version="1.0" encoding="utf-8"?>
 <p:sldLayout xmlns:a="http://schemas.openxmlformats.org/drawingml/2006/main" xmlns:r="http://schemas.openxmlformats.org/officeDocument/2006/relationships" xmlns:p="http://schemas.openxmlformats.org/presentationml/2006/main" type="secHead" preserve="1">
   <p:cSld name="Section Header">
+    <p:bg>
+      <p:bgPr>
+        <a:solidFill>
+          <a:srgbClr val="FFFFFF"/>
+        </a:solidFill>
+        <a:effectLst/>
+      </p:bgPr>
+    </p:bg>
     <p:spTree>
       <p:nvGrpSpPr>
         <p:cNvPr id="1" name=""/>
@@ -1458,6 +1827,49 @@
       </p:grpSpPr>
       <p:sp>
         <p:nvSpPr>
+          <p:cNvPr id="105" name="Rectangle 1"/>
+          <p:cNvSpPr/>
+          <p:nvPr/>
+        </p:nvSpPr>
+        <p:spPr>
+          <a:xfrm>
+            <a:off x="457200" y="1024128"/>
+            <a:ext cx="8229600" cy="50292"/>
+          </a:xfrm>
+          <a:prstGeom prst="rect">
+            <a:avLst/>
+          </a:prstGeom>
+          <a:solidFill>
+            <a:srgbClr val="49A9DF"/>
+          </a:solidFill>
+          <a:ln>
+            <a:noFill/>
+          </a:ln>
+        </p:spPr>
+        <p:style>
+          <a:lnRef idx="1">
+            <a:schemeClr val="accent1"/>
+          </a:lnRef>
+          <a:fillRef idx="3">
+            <a:schemeClr val="accent1"/>
+          </a:fillRef>
+          <a:effectRef idx="2">
+            <a:schemeClr val="accent1"/>
+          </a:effectRef>
+          <a:fontRef idx="minor">
+            <a:schemeClr val="lt1"/>
+          </a:fontRef>
+        </p:style>
+        <p:txBody>
+          <a:bodyPr rtlCol="0" anchor="ctr"/>
+          <a:lstStyle/>
+          <a:p>
+            <a:pPr algn="ctr"/>
+          </a:p>
+        </p:txBody>
+      </p:sp>
+      <p:sp>
+        <p:nvSpPr>
           <p:cNvPr id="2" name="Title 1"/>
           <p:cNvSpPr>
             <a:spLocks noGrp="1"/>
@@ -1480,6 +1892,14 @@
             </a:lvl1pPr>
           </a:lstStyle>
           <a:p>
+            <a:pPr>
+              <a:defRPr sz="3100" b="1">
+                <a:solidFill>
+                  <a:srgbClr val="0C2440"/>
+                </a:solidFill>
+                <a:latin typeface="Aptos Display"/>
+              </a:defRPr>
+            </a:pPr>
             <a:r>
               <a:rPr lang="en-US"/>
               <a:t>Click to edit Master title style</a:t>
@@ -1598,7 +2018,14 @@
             </a:lvl9pPr>
           </a:lstStyle>
           <a:p>
-            <a:pPr lvl="0"/>
+            <a:pPr lvl="0">
+              <a:defRPr sz="1900" b="0">
+                <a:solidFill>
+                  <a:srgbClr val="243A50"/>
+                </a:solidFill>
+                <a:latin typeface="Aptos"/>
+              </a:defRPr>
+            </a:pPr>
             <a:r>
               <a:rPr lang="en-US"/>
               <a:t>Click to edit Master text styles</a:t>
@@ -1621,6 +2048,14 @@
           <a:bodyPr/>
           <a:lstStyle/>
           <a:p>
+            <a:pPr>
+              <a:defRPr sz="900" b="0">
+                <a:solidFill>
+                  <a:srgbClr val="637D94"/>
+                </a:solidFill>
+                <a:latin typeface="Aptos"/>
+              </a:defRPr>
+            </a:pPr>
             <a:fld id="{241EB5C9-1307-BA42-ABA2-0BC069CD8E7F}" type="datetimeFigureOut">
               <a:rPr lang="en-US" smtClean="0"/>
               <a:t>1/2/22</a:t>
@@ -1644,6 +2079,14 @@
           <a:bodyPr/>
           <a:lstStyle/>
           <a:p>
+            <a:pPr>
+              <a:defRPr sz="900" b="0">
+                <a:solidFill>
+                  <a:srgbClr val="637D94"/>
+                </a:solidFill>
+                <a:latin typeface="Aptos"/>
+              </a:defRPr>
+            </a:pPr>
             <a:endParaRPr lang="en-US"/>
           </a:p>
         </p:txBody>
@@ -1663,6 +2106,14 @@
           <a:bodyPr/>
           <a:lstStyle/>
           <a:p>
+            <a:pPr>
+              <a:defRPr sz="900" b="0">
+                <a:solidFill>
+                  <a:srgbClr val="637D94"/>
+                </a:solidFill>
+                <a:latin typeface="Aptos"/>
+              </a:defRPr>
+            </a:pPr>
             <a:fld id="{C5EF2332-01BF-834F-8236-50238282D533}" type="slidenum">
               <a:rPr lang="en-US" smtClean="0"/>
               <a:t>‹#›</a:t>
@@ -1687,6 +2138,14 @@
 <file path=ppt/slideLayouts/slideLayout4.xml><?xml version="1.0" encoding="utf-8"?>
 <p:sldLayout xmlns:a="http://schemas.openxmlformats.org/drawingml/2006/main" xmlns:r="http://schemas.openxmlformats.org/officeDocument/2006/relationships" xmlns:p="http://schemas.openxmlformats.org/presentationml/2006/main" type="twoObj" preserve="1">
   <p:cSld name="Two Content">
+    <p:bg>
+      <p:bgPr>
+        <a:solidFill>
+          <a:srgbClr val="FFFFFF"/>
+        </a:solidFill>
+        <a:effectLst/>
+      </p:bgPr>
+    </p:bg>
     <p:spTree>
       <p:nvGrpSpPr>
         <p:cNvPr id="1" name=""/>
@@ -1703,6 +2162,49 @@
       </p:grpSpPr>
       <p:sp>
         <p:nvSpPr>
+          <p:cNvPr id="106" name="Rectangle 1"/>
+          <p:cNvSpPr/>
+          <p:nvPr/>
+        </p:nvSpPr>
+        <p:spPr>
+          <a:xfrm>
+            <a:off x="457200" y="1024128"/>
+            <a:ext cx="8229600" cy="50292"/>
+          </a:xfrm>
+          <a:prstGeom prst="rect">
+            <a:avLst/>
+          </a:prstGeom>
+          <a:solidFill>
+            <a:srgbClr val="49A9DF"/>
+          </a:solidFill>
+          <a:ln>
+            <a:noFill/>
+          </a:ln>
+        </p:spPr>
+        <p:style>
+          <a:lnRef idx="1">
+            <a:schemeClr val="accent1"/>
+          </a:lnRef>
+          <a:fillRef idx="3">
+            <a:schemeClr val="accent1"/>
+          </a:fillRef>
+          <a:effectRef idx="2">
+            <a:schemeClr val="accent1"/>
+          </a:effectRef>
+          <a:fontRef idx="minor">
+            <a:schemeClr val="lt1"/>
+          </a:fontRef>
+        </p:style>
+        <p:txBody>
+          <a:bodyPr rtlCol="0" anchor="ctr"/>
+          <a:lstStyle/>
+          <a:p>
+            <a:pPr algn="ctr"/>
+          </a:p>
+        </p:txBody>
+      </p:sp>
+      <p:sp>
+        <p:nvSpPr>
           <p:cNvPr id="2" name="Title 1"/>
           <p:cNvSpPr>
             <a:spLocks noGrp="1"/>
@@ -1716,6 +2218,14 @@
           <a:bodyPr/>
           <a:lstStyle/>
           <a:p>
+            <a:pPr>
+              <a:defRPr sz="3100" b="1">
+                <a:solidFill>
+                  <a:srgbClr val="0C2440"/>
+                </a:solidFill>
+                <a:latin typeface="Aptos Display"/>
+              </a:defRPr>
+            </a:pPr>
             <a:r>
               <a:rPr lang="en-US"/>
               <a:t>Click to edit Master title style</a:t>
@@ -1771,7 +2281,14 @@
             </a:lvl9pPr>
           </a:lstStyle>
           <a:p>
-            <a:pPr lvl="0"/>
+            <a:pPr lvl="0">
+              <a:defRPr sz="1900" b="0">
+                <a:solidFill>
+                  <a:srgbClr val="243A50"/>
+                </a:solidFill>
+                <a:latin typeface="Aptos"/>
+              </a:defRPr>
+            </a:pPr>
             <a:r>
               <a:rPr lang="en-US"/>
               <a:t>Click to edit Master text styles</a:t>
@@ -1855,7 +2372,14 @@
             </a:lvl9pPr>
           </a:lstStyle>
           <a:p>
-            <a:pPr lvl="0"/>
+            <a:pPr lvl="0">
+              <a:defRPr sz="1900" b="0">
+                <a:solidFill>
+                  <a:srgbClr val="243A50"/>
+                </a:solidFill>
+                <a:latin typeface="Aptos"/>
+              </a:defRPr>
+            </a:pPr>
             <a:r>
               <a:rPr lang="en-US"/>
               <a:t>Click to edit Master text styles</a:t>
@@ -1906,6 +2430,14 @@
           <a:bodyPr/>
           <a:lstStyle/>
           <a:p>
+            <a:pPr>
+              <a:defRPr sz="900" b="0">
+                <a:solidFill>
+                  <a:srgbClr val="637D94"/>
+                </a:solidFill>
+                <a:latin typeface="Aptos"/>
+              </a:defRPr>
+            </a:pPr>
             <a:fld id="{241EB5C9-1307-BA42-ABA2-0BC069CD8E7F}" type="datetimeFigureOut">
               <a:rPr lang="en-US" smtClean="0"/>
               <a:t>1/2/22</a:t>
@@ -1929,6 +2461,14 @@
           <a:bodyPr/>
           <a:lstStyle/>
           <a:p>
+            <a:pPr>
+              <a:defRPr sz="900" b="0">
+                <a:solidFill>
+                  <a:srgbClr val="637D94"/>
+                </a:solidFill>
+                <a:latin typeface="Aptos"/>
+              </a:defRPr>
+            </a:pPr>
             <a:endParaRPr lang="en-US"/>
           </a:p>
         </p:txBody>
@@ -1948,6 +2488,14 @@
           <a:bodyPr/>
           <a:lstStyle/>
           <a:p>
+            <a:pPr>
+              <a:defRPr sz="900" b="0">
+                <a:solidFill>
+                  <a:srgbClr val="637D94"/>
+                </a:solidFill>
+                <a:latin typeface="Aptos"/>
+              </a:defRPr>
+            </a:pPr>
             <a:fld id="{C5EF2332-01BF-834F-8236-50238282D533}" type="slidenum">
               <a:rPr lang="en-US" smtClean="0"/>
               <a:t>‹#›</a:t>
@@ -1972,6 +2520,14 @@
 <file path=ppt/slideLayouts/slideLayout5.xml><?xml version="1.0" encoding="utf-8"?>
 <p:sldLayout xmlns:a="http://schemas.openxmlformats.org/drawingml/2006/main" xmlns:r="http://schemas.openxmlformats.org/officeDocument/2006/relationships" xmlns:p="http://schemas.openxmlformats.org/presentationml/2006/main" type="twoTxTwoObj" preserve="1">
   <p:cSld name="Comparison">
+    <p:bg>
+      <p:bgPr>
+        <a:solidFill>
+          <a:srgbClr val="FFFFFF"/>
+        </a:solidFill>
+        <a:effectLst/>
+      </p:bgPr>
+    </p:bg>
     <p:spTree>
       <p:nvGrpSpPr>
         <p:cNvPr id="1" name=""/>
@@ -1988,6 +2544,49 @@
       </p:grpSpPr>
       <p:sp>
         <p:nvSpPr>
+          <p:cNvPr id="108" name="Rectangle 1"/>
+          <p:cNvSpPr/>
+          <p:nvPr/>
+        </p:nvSpPr>
+        <p:spPr>
+          <a:xfrm>
+            <a:off x="457200" y="1024128"/>
+            <a:ext cx="8229600" cy="50292"/>
+          </a:xfrm>
+          <a:prstGeom prst="rect">
+            <a:avLst/>
+          </a:prstGeom>
+          <a:solidFill>
+            <a:srgbClr val="49A9DF"/>
+          </a:solidFill>
+          <a:ln>
+            <a:noFill/>
+          </a:ln>
+        </p:spPr>
+        <p:style>
+          <a:lnRef idx="1">
+            <a:schemeClr val="accent1"/>
+          </a:lnRef>
+          <a:fillRef idx="3">
+            <a:schemeClr val="accent1"/>
+          </a:fillRef>
+          <a:effectRef idx="2">
+            <a:schemeClr val="accent1"/>
+          </a:effectRef>
+          <a:fontRef idx="minor">
+            <a:schemeClr val="lt1"/>
+          </a:fontRef>
+        </p:style>
+        <p:txBody>
+          <a:bodyPr rtlCol="0" anchor="ctr"/>
+          <a:lstStyle/>
+          <a:p>
+            <a:pPr algn="ctr"/>
+          </a:p>
+        </p:txBody>
+      </p:sp>
+      <p:sp>
+        <p:nvSpPr>
           <p:cNvPr id="2" name="Title 1"/>
           <p:cNvSpPr>
             <a:spLocks noGrp="1"/>
@@ -2005,6 +2604,14 @@
             </a:lvl1pPr>
           </a:lstStyle>
           <a:p>
+            <a:pPr>
+              <a:defRPr sz="3100" b="1">
+                <a:solidFill>
+                  <a:srgbClr val="0C2440"/>
+                </a:solidFill>
+                <a:latin typeface="Aptos Display"/>
+              </a:defRPr>
+            </a:pPr>
             <a:r>
               <a:rPr lang="en-US"/>
               <a:t>Click to edit Master title style</a:t>
@@ -2069,7 +2676,14 @@
             </a:lvl9pPr>
           </a:lstStyle>
           <a:p>
-            <a:pPr lvl="0"/>
+            <a:pPr lvl="0">
+              <a:defRPr sz="1900" b="0">
+                <a:solidFill>
+                  <a:srgbClr val="243A50"/>
+                </a:solidFill>
+                <a:latin typeface="Aptos"/>
+              </a:defRPr>
+            </a:pPr>
             <a:r>
               <a:rPr lang="en-US"/>
               <a:t>Click to edit Master text styles</a:t>
@@ -2125,7 +2739,14 @@
             </a:lvl9pPr>
           </a:lstStyle>
           <a:p>
-            <a:pPr lvl="0"/>
+            <a:pPr lvl="0">
+              <a:defRPr sz="1900" b="0">
+                <a:solidFill>
+                  <a:srgbClr val="243A50"/>
+                </a:solidFill>
+                <a:latin typeface="Aptos"/>
+              </a:defRPr>
+            </a:pPr>
             <a:r>
               <a:rPr lang="en-US"/>
               <a:t>Click to edit Master text styles</a:t>
@@ -2218,7 +2839,14 @@
             </a:lvl9pPr>
           </a:lstStyle>
           <a:p>
-            <a:pPr lvl="0"/>
+            <a:pPr lvl="0">
+              <a:defRPr sz="1900" b="0">
+                <a:solidFill>
+                  <a:srgbClr val="243A50"/>
+                </a:solidFill>
+                <a:latin typeface="Aptos"/>
+              </a:defRPr>
+            </a:pPr>
             <a:r>
               <a:rPr lang="en-US"/>
               <a:t>Click to edit Master text styles</a:t>
@@ -2274,7 +2902,14 @@
             </a:lvl9pPr>
           </a:lstStyle>
           <a:p>
-            <a:pPr lvl="0"/>
+            <a:pPr lvl="0">
+              <a:defRPr sz="1900" b="0">
+                <a:solidFill>
+                  <a:srgbClr val="243A50"/>
+                </a:solidFill>
+                <a:latin typeface="Aptos"/>
+              </a:defRPr>
+            </a:pPr>
             <a:r>
               <a:rPr lang="en-US"/>
               <a:t>Click to edit Master text styles</a:t>
@@ -2325,6 +2960,14 @@
           <a:bodyPr/>
           <a:lstStyle/>
           <a:p>
+            <a:pPr>
+              <a:defRPr sz="900" b="0">
+                <a:solidFill>
+                  <a:srgbClr val="637D94"/>
+                </a:solidFill>
+                <a:latin typeface="Aptos"/>
+              </a:defRPr>
+            </a:pPr>
             <a:fld id="{241EB5C9-1307-BA42-ABA2-0BC069CD8E7F}" type="datetimeFigureOut">
               <a:rPr lang="en-US" smtClean="0"/>
               <a:t>1/2/22</a:t>
@@ -2348,6 +2991,14 @@
           <a:bodyPr/>
           <a:lstStyle/>
           <a:p>
+            <a:pPr>
+              <a:defRPr sz="900" b="0">
+                <a:solidFill>
+                  <a:srgbClr val="637D94"/>
+                </a:solidFill>
+                <a:latin typeface="Aptos"/>
+              </a:defRPr>
+            </a:pPr>
             <a:endParaRPr lang="en-US"/>
           </a:p>
         </p:txBody>
@@ -2367,6 +3018,14 @@
           <a:bodyPr/>
           <a:lstStyle/>
           <a:p>
+            <a:pPr>
+              <a:defRPr sz="900" b="0">
+                <a:solidFill>
+                  <a:srgbClr val="637D94"/>
+                </a:solidFill>
+                <a:latin typeface="Aptos"/>
+              </a:defRPr>
+            </a:pPr>
             <a:fld id="{C5EF2332-01BF-834F-8236-50238282D533}" type="slidenum">
               <a:rPr lang="en-US" smtClean="0"/>
               <a:t>‹#›</a:t>
@@ -2391,6 +3050,14 @@
 <file path=ppt/slideLayouts/slideLayout6.xml><?xml version="1.0" encoding="utf-8"?>
 <p:sldLayout xmlns:a="http://schemas.openxmlformats.org/drawingml/2006/main" xmlns:r="http://schemas.openxmlformats.org/officeDocument/2006/relationships" xmlns:p="http://schemas.openxmlformats.org/presentationml/2006/main" type="titleOnly" preserve="1">
   <p:cSld name="Title Only">
+    <p:bg>
+      <p:bgPr>
+        <a:solidFill>
+          <a:srgbClr val="FFFFFF"/>
+        </a:solidFill>
+        <a:effectLst/>
+      </p:bgPr>
+    </p:bg>
     <p:spTree>
       <p:nvGrpSpPr>
         <p:cNvPr id="1" name=""/>
@@ -2407,6 +3074,49 @@
       </p:grpSpPr>
       <p:sp>
         <p:nvSpPr>
+          <p:cNvPr id="104" name="Rectangle 1"/>
+          <p:cNvSpPr/>
+          <p:nvPr/>
+        </p:nvSpPr>
+        <p:spPr>
+          <a:xfrm>
+            <a:off x="457200" y="1024128"/>
+            <a:ext cx="8229600" cy="50292"/>
+          </a:xfrm>
+          <a:prstGeom prst="rect">
+            <a:avLst/>
+          </a:prstGeom>
+          <a:solidFill>
+            <a:srgbClr val="49A9DF"/>
+          </a:solidFill>
+          <a:ln>
+            <a:noFill/>
+          </a:ln>
+        </p:spPr>
+        <p:style>
+          <a:lnRef idx="1">
+            <a:schemeClr val="accent1"/>
+          </a:lnRef>
+          <a:fillRef idx="3">
+            <a:schemeClr val="accent1"/>
+          </a:fillRef>
+          <a:effectRef idx="2">
+            <a:schemeClr val="accent1"/>
+          </a:effectRef>
+          <a:fontRef idx="minor">
+            <a:schemeClr val="lt1"/>
+          </a:fontRef>
+        </p:style>
+        <p:txBody>
+          <a:bodyPr rtlCol="0" anchor="ctr"/>
+          <a:lstStyle/>
+          <a:p>
+            <a:pPr algn="ctr"/>
+          </a:p>
+        </p:txBody>
+      </p:sp>
+      <p:sp>
+        <p:nvSpPr>
           <p:cNvPr id="2" name="Title 1"/>
           <p:cNvSpPr>
             <a:spLocks noGrp="1"/>
@@ -2420,6 +3130,14 @@
           <a:bodyPr/>
           <a:lstStyle/>
           <a:p>
+            <a:pPr>
+              <a:defRPr sz="3100" b="1">
+                <a:solidFill>
+                  <a:srgbClr val="0C2440"/>
+                </a:solidFill>
+                <a:latin typeface="Aptos Display"/>
+              </a:defRPr>
+            </a:pPr>
             <a:r>
               <a:rPr lang="en-US"/>
               <a:t>Click to edit Master title style</a:t>
@@ -2442,6 +3160,14 @@
           <a:bodyPr/>
           <a:lstStyle/>
           <a:p>
+            <a:pPr>
+              <a:defRPr sz="900" b="0">
+                <a:solidFill>
+                  <a:srgbClr val="637D94"/>
+                </a:solidFill>
+                <a:latin typeface="Aptos"/>
+              </a:defRPr>
+            </a:pPr>
             <a:fld id="{241EB5C9-1307-BA42-ABA2-0BC069CD8E7F}" type="datetimeFigureOut">
               <a:rPr lang="en-US" smtClean="0"/>
               <a:t>1/2/22</a:t>
@@ -2465,6 +3191,14 @@
           <a:bodyPr/>
           <a:lstStyle/>
           <a:p>
+            <a:pPr>
+              <a:defRPr sz="900" b="0">
+                <a:solidFill>
+                  <a:srgbClr val="637D94"/>
+                </a:solidFill>
+                <a:latin typeface="Aptos"/>
+              </a:defRPr>
+            </a:pPr>
             <a:endParaRPr lang="en-US"/>
           </a:p>
         </p:txBody>
@@ -2484,6 +3218,14 @@
           <a:bodyPr/>
           <a:lstStyle/>
           <a:p>
+            <a:pPr>
+              <a:defRPr sz="900" b="0">
+                <a:solidFill>
+                  <a:srgbClr val="637D94"/>
+                </a:solidFill>
+                <a:latin typeface="Aptos"/>
+              </a:defRPr>
+            </a:pPr>
             <a:fld id="{C5EF2332-01BF-834F-8236-50238282D533}" type="slidenum">
               <a:rPr lang="en-US" smtClean="0"/>
               <a:t>‹#›</a:t>
@@ -2508,6 +3250,14 @@
 <file path=ppt/slideLayouts/slideLayout7.xml><?xml version="1.0" encoding="utf-8"?>
 <p:sldLayout xmlns:a="http://schemas.openxmlformats.org/drawingml/2006/main" xmlns:r="http://schemas.openxmlformats.org/officeDocument/2006/relationships" xmlns:p="http://schemas.openxmlformats.org/presentationml/2006/main" type="blank" preserve="1">
   <p:cSld name="Blank">
+    <p:bg>
+      <p:bgPr>
+        <a:solidFill>
+          <a:srgbClr val="FFFFFF"/>
+        </a:solidFill>
+        <a:effectLst/>
+      </p:bgPr>
+    </p:bg>
     <p:spTree>
       <p:nvGrpSpPr>
         <p:cNvPr id="1" name=""/>
@@ -2524,6 +3274,49 @@
       </p:grpSpPr>
       <p:sp>
         <p:nvSpPr>
+          <p:cNvPr id="103" name="Rectangle 1"/>
+          <p:cNvSpPr/>
+          <p:nvPr/>
+        </p:nvSpPr>
+        <p:spPr>
+          <a:xfrm>
+            <a:off x="457200" y="1024128"/>
+            <a:ext cx="8229600" cy="50292"/>
+          </a:xfrm>
+          <a:prstGeom prst="rect">
+            <a:avLst/>
+          </a:prstGeom>
+          <a:solidFill>
+            <a:srgbClr val="49A9DF"/>
+          </a:solidFill>
+          <a:ln>
+            <a:noFill/>
+          </a:ln>
+        </p:spPr>
+        <p:style>
+          <a:lnRef idx="1">
+            <a:schemeClr val="accent1"/>
+          </a:lnRef>
+          <a:fillRef idx="3">
+            <a:schemeClr val="accent1"/>
+          </a:fillRef>
+          <a:effectRef idx="2">
+            <a:schemeClr val="accent1"/>
+          </a:effectRef>
+          <a:fontRef idx="minor">
+            <a:schemeClr val="lt1"/>
+          </a:fontRef>
+        </p:style>
+        <p:txBody>
+          <a:bodyPr rtlCol="0" anchor="ctr"/>
+          <a:lstStyle/>
+          <a:p>
+            <a:pPr algn="ctr"/>
+          </a:p>
+        </p:txBody>
+      </p:sp>
+      <p:sp>
+        <p:nvSpPr>
           <p:cNvPr id="2" name="Date Placeholder 1"/>
           <p:cNvSpPr>
             <a:spLocks noGrp="1"/>
@@ -2537,6 +3330,14 @@
           <a:bodyPr/>
           <a:lstStyle/>
           <a:p>
+            <a:pPr>
+              <a:defRPr sz="900" b="0">
+                <a:solidFill>
+                  <a:srgbClr val="637D94"/>
+                </a:solidFill>
+                <a:latin typeface="Aptos"/>
+              </a:defRPr>
+            </a:pPr>
             <a:fld id="{241EB5C9-1307-BA42-ABA2-0BC069CD8E7F}" type="datetimeFigureOut">
               <a:rPr lang="en-US" smtClean="0"/>
               <a:t>1/2/22</a:t>
@@ -2560,6 +3361,14 @@
           <a:bodyPr/>
           <a:lstStyle/>
           <a:p>
+            <a:pPr>
+              <a:defRPr sz="900" b="0">
+                <a:solidFill>
+                  <a:srgbClr val="637D94"/>
+                </a:solidFill>
+                <a:latin typeface="Aptos"/>
+              </a:defRPr>
+            </a:pPr>
             <a:endParaRPr lang="en-US"/>
           </a:p>
         </p:txBody>
@@ -2579,6 +3388,14 @@
           <a:bodyPr/>
           <a:lstStyle/>
           <a:p>
+            <a:pPr>
+              <a:defRPr sz="900" b="0">
+                <a:solidFill>
+                  <a:srgbClr val="637D94"/>
+                </a:solidFill>
+                <a:latin typeface="Aptos"/>
+              </a:defRPr>
+            </a:pPr>
             <a:fld id="{C5EF2332-01BF-834F-8236-50238282D533}" type="slidenum">
               <a:rPr lang="en-US" smtClean="0"/>
               <a:t>‹#›</a:t>
@@ -2603,6 +3420,14 @@
 <file path=ppt/slideLayouts/slideLayout8.xml><?xml version="1.0" encoding="utf-8"?>
 <p:sldLayout xmlns:a="http://schemas.openxmlformats.org/drawingml/2006/main" xmlns:r="http://schemas.openxmlformats.org/officeDocument/2006/relationships" xmlns:p="http://schemas.openxmlformats.org/presentationml/2006/main" type="objTx" preserve="1">
   <p:cSld name="Content with Caption">
+    <p:bg>
+      <p:bgPr>
+        <a:solidFill>
+          <a:srgbClr val="FFFFFF"/>
+        </a:solidFill>
+        <a:effectLst/>
+      </p:bgPr>
+    </p:bg>
     <p:spTree>
       <p:nvGrpSpPr>
         <p:cNvPr id="1" name=""/>
@@ -2619,6 +3444,49 @@
       </p:grpSpPr>
       <p:sp>
         <p:nvSpPr>
+          <p:cNvPr id="106" name="Rectangle 1"/>
+          <p:cNvSpPr/>
+          <p:nvPr/>
+        </p:nvSpPr>
+        <p:spPr>
+          <a:xfrm>
+            <a:off x="457200" y="1024128"/>
+            <a:ext cx="8229600" cy="50292"/>
+          </a:xfrm>
+          <a:prstGeom prst="rect">
+            <a:avLst/>
+          </a:prstGeom>
+          <a:solidFill>
+            <a:srgbClr val="49A9DF"/>
+          </a:solidFill>
+          <a:ln>
+            <a:noFill/>
+          </a:ln>
+        </p:spPr>
+        <p:style>
+          <a:lnRef idx="1">
+            <a:schemeClr val="accent1"/>
+          </a:lnRef>
+          <a:fillRef idx="3">
+            <a:schemeClr val="accent1"/>
+          </a:fillRef>
+          <a:effectRef idx="2">
+            <a:schemeClr val="accent1"/>
+          </a:effectRef>
+          <a:fontRef idx="minor">
+            <a:schemeClr val="lt1"/>
+          </a:fontRef>
+        </p:style>
+        <p:txBody>
+          <a:bodyPr rtlCol="0" anchor="ctr"/>
+          <a:lstStyle/>
+          <a:p>
+            <a:pPr algn="ctr"/>
+          </a:p>
+        </p:txBody>
+      </p:sp>
+      <p:sp>
+        <p:nvSpPr>
           <p:cNvPr id="2" name="Title 1"/>
           <p:cNvSpPr>
             <a:spLocks noGrp="1"/>
@@ -2641,6 +3509,14 @@
             </a:lvl1pPr>
           </a:lstStyle>
           <a:p>
+            <a:pPr>
+              <a:defRPr sz="3100" b="1">
+                <a:solidFill>
+                  <a:srgbClr val="0C2440"/>
+                </a:solidFill>
+                <a:latin typeface="Aptos Display"/>
+              </a:defRPr>
+            </a:pPr>
             <a:r>
               <a:rPr lang="en-US"/>
               <a:t>Click to edit Master title style</a:t>
@@ -2696,7 +3572,14 @@
             </a:lvl9pPr>
           </a:lstStyle>
           <a:p>
-            <a:pPr lvl="0"/>
+            <a:pPr lvl="0">
+              <a:defRPr sz="1900" b="0">
+                <a:solidFill>
+                  <a:srgbClr val="243A50"/>
+                </a:solidFill>
+                <a:latin typeface="Aptos"/>
+              </a:defRPr>
+            </a:pPr>
             <a:r>
               <a:rPr lang="en-US"/>
               <a:t>Click to edit Master text styles</a:t>
@@ -2789,7 +3672,14 @@
             </a:lvl9pPr>
           </a:lstStyle>
           <a:p>
-            <a:pPr lvl="0"/>
+            <a:pPr lvl="0">
+              <a:defRPr sz="1900" b="0">
+                <a:solidFill>
+                  <a:srgbClr val="243A50"/>
+                </a:solidFill>
+                <a:latin typeface="Aptos"/>
+              </a:defRPr>
+            </a:pPr>
             <a:r>
               <a:rPr lang="en-US"/>
               <a:t>Click to edit Master text styles</a:t>
@@ -2812,6 +3702,14 @@
           <a:bodyPr/>
           <a:lstStyle/>
           <a:p>
+            <a:pPr>
+              <a:defRPr sz="900" b="0">
+                <a:solidFill>
+                  <a:srgbClr val="637D94"/>
+                </a:solidFill>
+                <a:latin typeface="Aptos"/>
+              </a:defRPr>
+            </a:pPr>
             <a:fld id="{241EB5C9-1307-BA42-ABA2-0BC069CD8E7F}" type="datetimeFigureOut">
               <a:rPr lang="en-US" smtClean="0"/>
               <a:t>1/2/22</a:t>
@@ -2835,6 +3733,14 @@
           <a:bodyPr/>
           <a:lstStyle/>
           <a:p>
+            <a:pPr>
+              <a:defRPr sz="900" b="0">
+                <a:solidFill>
+                  <a:srgbClr val="637D94"/>
+                </a:solidFill>
+                <a:latin typeface="Aptos"/>
+              </a:defRPr>
+            </a:pPr>
             <a:endParaRPr lang="en-US"/>
           </a:p>
         </p:txBody>
@@ -2854,6 +3760,14 @@
           <a:bodyPr/>
           <a:lstStyle/>
           <a:p>
+            <a:pPr>
+              <a:defRPr sz="900" b="0">
+                <a:solidFill>
+                  <a:srgbClr val="637D94"/>
+                </a:solidFill>
+                <a:latin typeface="Aptos"/>
+              </a:defRPr>
+            </a:pPr>
             <a:fld id="{C5EF2332-01BF-834F-8236-50238282D533}" type="slidenum">
               <a:rPr lang="en-US" smtClean="0"/>
               <a:t>‹#›</a:t>
@@ -2878,6 +3792,14 @@
 <file path=ppt/slideLayouts/slideLayout9.xml><?xml version="1.0" encoding="utf-8"?>
 <p:sldLayout xmlns:a="http://schemas.openxmlformats.org/drawingml/2006/main" xmlns:r="http://schemas.openxmlformats.org/officeDocument/2006/relationships" xmlns:p="http://schemas.openxmlformats.org/presentationml/2006/main" type="picTx" preserve="1">
   <p:cSld name="Picture with Caption">
+    <p:bg>
+      <p:bgPr>
+        <a:solidFill>
+          <a:srgbClr val="FFFFFF"/>
+        </a:solidFill>
+        <a:effectLst/>
+      </p:bgPr>
+    </p:bg>
     <p:spTree>
       <p:nvGrpSpPr>
         <p:cNvPr id="1" name=""/>
@@ -2894,6 +3816,49 @@
       </p:grpSpPr>
       <p:sp>
         <p:nvSpPr>
+          <p:cNvPr id="106" name="Rectangle 1"/>
+          <p:cNvSpPr/>
+          <p:nvPr/>
+        </p:nvSpPr>
+        <p:spPr>
+          <a:xfrm>
+            <a:off x="457200" y="1024128"/>
+            <a:ext cx="8229600" cy="50292"/>
+          </a:xfrm>
+          <a:prstGeom prst="rect">
+            <a:avLst/>
+          </a:prstGeom>
+          <a:solidFill>
+            <a:srgbClr val="49A9DF"/>
+          </a:solidFill>
+          <a:ln>
+            <a:noFill/>
+          </a:ln>
+        </p:spPr>
+        <p:style>
+          <a:lnRef idx="1">
+            <a:schemeClr val="accent1"/>
+          </a:lnRef>
+          <a:fillRef idx="3">
+            <a:schemeClr val="accent1"/>
+          </a:fillRef>
+          <a:effectRef idx="2">
+            <a:schemeClr val="accent1"/>
+          </a:effectRef>
+          <a:fontRef idx="minor">
+            <a:schemeClr val="lt1"/>
+          </a:fontRef>
+        </p:style>
+        <p:txBody>
+          <a:bodyPr rtlCol="0" anchor="ctr"/>
+          <a:lstStyle/>
+          <a:p>
+            <a:pPr algn="ctr"/>
+          </a:p>
+        </p:txBody>
+      </p:sp>
+      <p:sp>
+        <p:nvSpPr>
           <p:cNvPr id="2" name="Title 1"/>
           <p:cNvSpPr>
             <a:spLocks noGrp="1"/>
@@ -2916,6 +3881,14 @@
             </a:lvl1pPr>
           </a:lstStyle>
           <a:p>
+            <a:pPr>
+              <a:defRPr sz="3100" b="1">
+                <a:solidFill>
+                  <a:srgbClr val="0C2440"/>
+                </a:solidFill>
+                <a:latin typeface="Aptos Display"/>
+              </a:defRPr>
+            </a:pPr>
             <a:r>
               <a:rPr lang="en-US"/>
               <a:t>Click to edit Master title style</a:t>
@@ -2980,6 +3953,14 @@
             </a:lvl9pPr>
           </a:lstStyle>
           <a:p>
+            <a:pPr>
+              <a:defRPr sz="1900" b="0">
+                <a:solidFill>
+                  <a:srgbClr val="243A50"/>
+                </a:solidFill>
+                <a:latin typeface="Aptos"/>
+              </a:defRPr>
+            </a:pPr>
             <a:endParaRPr lang="en-US"/>
           </a:p>
         </p:txBody>
@@ -3041,7 +4022,14 @@
             </a:lvl9pPr>
           </a:lstStyle>
           <a:p>
-            <a:pPr lvl="0"/>
+            <a:pPr lvl="0">
+              <a:defRPr sz="1900" b="0">
+                <a:solidFill>
+                  <a:srgbClr val="243A50"/>
+                </a:solidFill>
+                <a:latin typeface="Aptos"/>
+              </a:defRPr>
+            </a:pPr>
             <a:r>
               <a:rPr lang="en-US"/>
               <a:t>Click to edit Master text styles</a:t>
@@ -3064,6 +4052,14 @@
           <a:bodyPr/>
           <a:lstStyle/>
           <a:p>
+            <a:pPr>
+              <a:defRPr sz="900" b="0">
+                <a:solidFill>
+                  <a:srgbClr val="637D94"/>
+                </a:solidFill>
+                <a:latin typeface="Aptos"/>
+              </a:defRPr>
+            </a:pPr>
             <a:fld id="{241EB5C9-1307-BA42-ABA2-0BC069CD8E7F}" type="datetimeFigureOut">
               <a:rPr lang="en-US" smtClean="0"/>
               <a:t>1/2/22</a:t>
@@ -3087,6 +4083,14 @@
           <a:bodyPr/>
           <a:lstStyle/>
           <a:p>
+            <a:pPr>
+              <a:defRPr sz="900" b="0">
+                <a:solidFill>
+                  <a:srgbClr val="637D94"/>
+                </a:solidFill>
+                <a:latin typeface="Aptos"/>
+              </a:defRPr>
+            </a:pPr>
             <a:endParaRPr lang="en-US"/>
           </a:p>
         </p:txBody>
@@ -3106,6 +4110,14 @@
           <a:bodyPr/>
           <a:lstStyle/>
           <a:p>
+            <a:pPr>
+              <a:defRPr sz="900" b="0">
+                <a:solidFill>
+                  <a:srgbClr val="637D94"/>
+                </a:solidFill>
+                <a:latin typeface="Aptos"/>
+              </a:defRPr>
+            </a:pPr>
             <a:fld id="{C5EF2332-01BF-834F-8236-50238282D533}" type="slidenum">
               <a:rPr lang="en-US" smtClean="0"/>
               <a:t>‹#›</a:t>
@@ -3964,42 +4976,42 @@
 <file path=ppt/theme/theme1.xml><?xml version="1.0" encoding="utf-8"?>
 <ns0:theme xmlns:ns0="http://schemas.openxmlformats.org/drawingml/2006/main" name="Office Theme">
   <ns0:themeElements>
-    <ns0:clrScheme name="SlateIndigoSky">
+    <ns0:clrScheme name="AzulRelatorio2026">
       <ns0:dk1>
-        <ns0:sysClr val="windowText" lastClr="1E293B"/>
+        <ns0:sysClr val="windowText" lastClr="0C2440"/>
       </ns0:dk1>
       <ns0:lt1>
-        <ns0:sysClr val="window" lastClr="F8FAFC"/>
+        <ns0:sysClr val="window" lastClr="FFFFFF"/>
       </ns0:lt1>
       <ns0:dk2>
-        <ns0:srgbClr val="334155"/>
+        <ns0:srgbClr val="243A50"/>
       </ns0:dk2>
       <ns0:lt2>
-        <ns0:srgbClr val="E2E8F0"/>
+        <ns0:srgbClr val="EAF4FB"/>
       </ns0:lt2>
       <ns0:accent1>
-        <ns0:srgbClr val="4F46E5"/>
+        <ns0:srgbClr val="176FC1"/>
       </ns0:accent1>
       <ns0:accent2>
-        <ns0:srgbClr val="0EA5E9"/>
+        <ns0:srgbClr val="49A9DF"/>
       </ns0:accent2>
       <ns0:accent3>
-        <ns0:srgbClr val="6366F1"/>
+        <ns0:srgbClr val="119DA4"/>
       </ns0:accent3>
       <ns0:accent4>
-        <ns0:srgbClr val="0284C7"/>
+        <ns0:srgbClr val="8CA9C0"/>
       </ns0:accent4>
       <ns0:accent5>
-        <ns0:srgbClr val="64748B"/>
+        <ns0:srgbClr val="637D94"/>
       </ns0:accent5>
       <ns0:accent6>
-        <ns0:srgbClr val="38BDF8"/>
+        <ns0:srgbClr val="CBE8F9"/>
       </ns0:accent6>
       <ns0:hlink>
-        <ns0:srgbClr val="4F46E5"/>
+        <ns0:srgbClr val="176FC1"/>
       </ns0:hlink>
       <ns0:folHlink>
-        <ns0:srgbClr val="0284C7"/>
+        <ns0:srgbClr val="135D9B"/>
       </ns0:folHlink>
     </ns0:clrScheme>
     <ns0:fontScheme name="Office">
@@ -4284,42 +5296,42 @@
 <file path=ppt/theme/theme2.xml><?xml version="1.0" encoding="utf-8"?>
 <ns0:theme xmlns:ns0="http://schemas.openxmlformats.org/drawingml/2006/main" xmlns:ns1="http://schemas.microsoft.com/office/thememl/2012/main" name="Office Theme">
   <ns0:themeElements>
-    <ns0:clrScheme name="SlateIndigoSky">
+    <ns0:clrScheme name="AzulRelatorio2026">
       <ns0:dk1>
-        <ns0:sysClr val="windowText" lastClr="1E293B"/>
+        <ns0:sysClr val="windowText" lastClr="0C2440"/>
       </ns0:dk1>
       <ns0:lt1>
-        <ns0:sysClr val="window" lastClr="F8FAFC"/>
+        <ns0:sysClr val="window" lastClr="FFFFFF"/>
       </ns0:lt1>
       <ns0:dk2>
-        <ns0:srgbClr val="334155"/>
+        <ns0:srgbClr val="243A50"/>
       </ns0:dk2>
       <ns0:lt2>
-        <ns0:srgbClr val="E2E8F0"/>
+        <ns0:srgbClr val="EAF4FB"/>
       </ns0:lt2>
       <ns0:accent1>
-        <ns0:srgbClr val="4F46E5"/>
+        <ns0:srgbClr val="176FC1"/>
       </ns0:accent1>
       <ns0:accent2>
-        <ns0:srgbClr val="0EA5E9"/>
+        <ns0:srgbClr val="49A9DF"/>
       </ns0:accent2>
       <ns0:accent3>
-        <ns0:srgbClr val="6366F1"/>
+        <ns0:srgbClr val="119DA4"/>
       </ns0:accent3>
       <ns0:accent4>
-        <ns0:srgbClr val="0284C7"/>
+        <ns0:srgbClr val="8CA9C0"/>
       </ns0:accent4>
       <ns0:accent5>
-        <ns0:srgbClr val="64748B"/>
+        <ns0:srgbClr val="637D94"/>
       </ns0:accent5>
       <ns0:accent6>
-        <ns0:srgbClr val="38BDF8"/>
+        <ns0:srgbClr val="CBE8F9"/>
       </ns0:accent6>
       <ns0:hlink>
-        <ns0:srgbClr val="4F46E5"/>
+        <ns0:srgbClr val="176FC1"/>
       </ns0:hlink>
       <ns0:folHlink>
-        <ns0:srgbClr val="0284C7"/>
+        <ns0:srgbClr val="135D9B"/>
       </ns0:folHlink>
     </ns0:clrScheme>
     <ns0:fontScheme name="Office">

</xml_diff>